<commit_message>
fix(memoria): fix CORRECTIONS FRO ORESTI, TEXT
</commit_message>
<xml_diff>
--- a/tfm_defensa.pptx
+++ b/tfm_defensa.pptx
@@ -2159,13 +2159,599 @@
       </p:sp>
       <p:sp>
         <p:nvSpPr>
-          <p:cNvPr id="3" name="Shape 1"/>
+          <p:cNvPr id="4" name="Text 2"/>
+          <p:cNvSpPr txBox="1"/>
+          <p:nvPr/>
+        </p:nvSpPr>
+        <p:spPr>
+          <a:xfrm>
+            <a:off x="8229600" y="4869180"/>
+            <a:ext cx="777240" cy="201168"/>
+          </a:xfrm>
+          <a:prstGeom prst="rect">
+            <a:avLst/>
+          </a:prstGeom>
+          <a:noFill/>
+          <a:ln/>
+        </p:spPr>
+        <p:txBody>
+          <a:bodyPr wrap="square" rtlCol="0" anchor="ctr"/>
+          <a:lstStyle/>
+          <a:p>
+            <a:pPr marL="0" indent="0" algn="r">
+              <a:buNone/>
+            </a:pPr>
+            <a:r>
+              <a:rPr lang="en-US" sz="1200" dirty="0">
+                <a:solidFill>
+                  <a:srgbClr val="7F8C8D"/>
+                </a:solidFill>
+              </a:rPr>
+              <a:t>10 / 12</a:t>
+            </a:r>
+            <a:endParaRPr lang="en-US" sz="1200" dirty="0"/>
+          </a:p>
+        </p:txBody>
+      </p:sp>
+      <p:sp>
+        <p:nvSpPr>
+          <p:cNvPr id="5" name="Shape 3"/>
           <p:cNvSpPr/>
           <p:nvPr/>
         </p:nvSpPr>
         <p:spPr>
           <a:xfrm>
-            <a:off x="502920" y="4686300"/>
+            <a:off x="502920" y="1170432"/>
+            <a:ext cx="8138160" cy="685800"/>
+          </a:xfrm>
+          <a:prstGeom prst="rect">
+            <a:avLst/>
+          </a:prstGeom>
+          <a:solidFill>
+            <a:srgbClr val="FEF9E7"/>
+          </a:solidFill>
+          <a:ln w="12700">
+            <a:solidFill>
+              <a:srgbClr val="FEF9E7"/>
+            </a:solidFill>
+            <a:prstDash val="solid"/>
+          </a:ln>
+        </p:spPr>
+        <p:txBody>
+          <a:bodyPr/>
+          <a:lstStyle/>
+          <a:p>
+            <a:endParaRPr lang="es-ES"/>
+          </a:p>
+        </p:txBody>
+      </p:sp>
+      <p:sp>
+        <p:nvSpPr>
+          <p:cNvPr id="6" name="Shape 4"/>
+          <p:cNvSpPr/>
+          <p:nvPr/>
+        </p:nvSpPr>
+        <p:spPr>
+          <a:xfrm>
+            <a:off x="502920" y="1170432"/>
+            <a:ext cx="64008" cy="685800"/>
+          </a:xfrm>
+          <a:prstGeom prst="rect">
+            <a:avLst/>
+          </a:prstGeom>
+          <a:solidFill>
+            <a:srgbClr val="E67E22"/>
+          </a:solidFill>
+          <a:ln w="12700">
+            <a:solidFill>
+              <a:srgbClr val="E67E22"/>
+            </a:solidFill>
+            <a:prstDash val="solid"/>
+          </a:ln>
+        </p:spPr>
+        <p:txBody>
+          <a:bodyPr/>
+          <a:lstStyle/>
+          <a:p>
+            <a:endParaRPr lang="es-ES"/>
+          </a:p>
+        </p:txBody>
+      </p:sp>
+      <p:sp>
+        <p:nvSpPr>
+          <p:cNvPr id="7" name="Text 5"/>
+          <p:cNvSpPr txBox="1"/>
+          <p:nvPr/>
+        </p:nvSpPr>
+        <p:spPr>
+          <a:xfrm>
+            <a:off x="640080" y="1188720"/>
+            <a:ext cx="3657600" cy="256032"/>
+          </a:xfrm>
+          <a:prstGeom prst="rect">
+            <a:avLst/>
+          </a:prstGeom>
+          <a:noFill/>
+          <a:ln/>
+        </p:spPr>
+        <p:txBody>
+          <a:bodyPr wrap="square" rtlCol="0" anchor="ctr"/>
+          <a:lstStyle/>
+          <a:p>
+            <a:pPr marL="0" indent="0">
+              <a:buNone/>
+            </a:pPr>
+            <a:r>
+              <a:rPr lang="en-US" sz="1400" b="1" dirty="0">
+                <a:solidFill>
+                  <a:srgbClr val="E67E22"/>
+                </a:solidFill>
+              </a:rPr>
+              <a:t>La paradoja observada</a:t>
+            </a:r>
+            <a:endParaRPr lang="en-US" sz="1400" dirty="0"/>
+          </a:p>
+        </p:txBody>
+      </p:sp>
+      <p:sp>
+        <p:nvSpPr>
+          <p:cNvPr id="8" name="Text 6"/>
+          <p:cNvSpPr txBox="1"/>
+          <p:nvPr/>
+        </p:nvSpPr>
+        <p:spPr>
+          <a:xfrm>
+            <a:off x="640080" y="1463040"/>
+            <a:ext cx="7909560" cy="347472"/>
+          </a:xfrm>
+          <a:prstGeom prst="rect">
+            <a:avLst/>
+          </a:prstGeom>
+          <a:noFill/>
+          <a:ln/>
+        </p:spPr>
+        <p:txBody>
+          <a:bodyPr wrap="square" rtlCol="0" anchor="ctr"/>
+          <a:lstStyle/>
+          <a:p>
+            <a:pPr marL="0" indent="0">
+              <a:buNone/>
+            </a:pPr>
+            <a:r>
+              <a:rPr lang="en-US" sz="1100" dirty="0">
+                <a:solidFill>
+                  <a:srgbClr val="1A1A2E"/>
+                </a:solidFill>
+              </a:rPr>
+              <a:t>El dataset más pequeño (DiaTrend, 51 pac.) produce los rankings de técnicas más consistentes entre folds (Spearman &gt; 0,78). El dataset más grande (T1DiabetesGranada, 643 pac.) produce los rankings menos reproducibles (Spearman ≈ 0,01–0,36).</a:t>
+            </a:r>
+            <a:endParaRPr lang="en-US" sz="1100" dirty="0"/>
+          </a:p>
+        </p:txBody>
+      </p:sp>
+      <p:sp>
+        <p:nvSpPr>
+          <p:cNvPr id="9" name="Shape 7"/>
+          <p:cNvSpPr/>
+          <p:nvPr/>
+        </p:nvSpPr>
+        <p:spPr>
+          <a:xfrm>
+            <a:off x="502920" y="2282952"/>
+            <a:ext cx="4069080" cy="1380744"/>
+          </a:xfrm>
+          <a:prstGeom prst="rect">
+            <a:avLst/>
+          </a:prstGeom>
+          <a:solidFill>
+            <a:srgbClr val="F2F4F8"/>
+          </a:solidFill>
+          <a:ln w="12700">
+            <a:solidFill>
+              <a:srgbClr val="F2F4F8"/>
+            </a:solidFill>
+            <a:prstDash val="solid"/>
+          </a:ln>
+        </p:spPr>
+        <p:txBody>
+          <a:bodyPr/>
+          <a:lstStyle/>
+          <a:p>
+            <a:endParaRPr lang="es-ES"/>
+          </a:p>
+        </p:txBody>
+      </p:sp>
+      <p:sp>
+        <p:nvSpPr>
+          <p:cNvPr id="10" name="Shape 8"/>
+          <p:cNvSpPr/>
+          <p:nvPr/>
+        </p:nvSpPr>
+        <p:spPr>
+          <a:xfrm>
+            <a:off x="502920" y="2282952"/>
+            <a:ext cx="4069080" cy="64008"/>
+          </a:xfrm>
+          <a:prstGeom prst="rect">
+            <a:avLst/>
+          </a:prstGeom>
+          <a:solidFill>
+            <a:srgbClr val="1B4F72"/>
+          </a:solidFill>
+          <a:ln w="12700">
+            <a:solidFill>
+              <a:srgbClr val="1B4F72"/>
+            </a:solidFill>
+            <a:prstDash val="solid"/>
+          </a:ln>
+        </p:spPr>
+        <p:txBody>
+          <a:bodyPr/>
+          <a:lstStyle/>
+          <a:p>
+            <a:endParaRPr lang="es-ES"/>
+          </a:p>
+        </p:txBody>
+      </p:sp>
+      <p:sp>
+        <p:nvSpPr>
+          <p:cNvPr id="11" name="Text 9"/>
+          <p:cNvSpPr txBox="1"/>
+          <p:nvPr/>
+        </p:nvSpPr>
+        <p:spPr>
+          <a:xfrm>
+            <a:off x="594360" y="2401824"/>
+            <a:ext cx="3886200" cy="347472"/>
+          </a:xfrm>
+          <a:prstGeom prst="rect">
+            <a:avLst/>
+          </a:prstGeom>
+          <a:noFill/>
+          <a:ln/>
+        </p:spPr>
+        <p:txBody>
+          <a:bodyPr wrap="square" rtlCol="0" anchor="ctr"/>
+          <a:lstStyle/>
+          <a:p>
+            <a:pPr marL="0" indent="0">
+              <a:buNone/>
+            </a:pPr>
+            <a:r>
+              <a:rPr lang="en-US" sz="1400" b="1" dirty="0">
+                <a:solidFill>
+                  <a:srgbClr val="1A1A2E"/>
+                </a:solidFill>
+              </a:rPr>
+              <a:t>¿Por qué DiaTrend es consistente?</a:t>
+            </a:r>
+            <a:endParaRPr lang="en-US" sz="1400" dirty="0"/>
+          </a:p>
+        </p:txBody>
+      </p:sp>
+      <p:sp>
+        <p:nvSpPr>
+          <p:cNvPr id="12" name="Text 10"/>
+          <p:cNvSpPr txBox="1"/>
+          <p:nvPr/>
+        </p:nvSpPr>
+        <p:spPr>
+          <a:xfrm>
+            <a:off x="594360" y="2759964"/>
+            <a:ext cx="3886200" cy="844296"/>
+          </a:xfrm>
+          <a:prstGeom prst="rect">
+            <a:avLst/>
+          </a:prstGeom>
+          <a:noFill/>
+          <a:ln/>
+        </p:spPr>
+        <p:txBody>
+          <a:bodyPr wrap="square" rtlCol="0" anchor="ctr"/>
+          <a:lstStyle/>
+          <a:p>
+            <a:pPr marL="0" indent="0">
+              <a:buNone/>
+            </a:pPr>
+            <a:r>
+              <a:rPr lang="en-US" sz="1100" dirty="0">
+                <a:solidFill>
+                  <a:srgbClr val="1A1A2E"/>
+                </a:solidFill>
+              </a:rPr>
+              <a:t>El desequilibrio extremo (38:1 por edad) actúa como señal dominante de varianza. El sesgo gobierna el comportamiento del optimizador de forma idéntica en todos los folds, independientemente de qué pacientes concretos los componen.</a:t>
+            </a:r>
+            <a:endParaRPr lang="en-US" sz="1100" dirty="0"/>
+          </a:p>
+        </p:txBody>
+      </p:sp>
+      <p:sp>
+        <p:nvSpPr>
+          <p:cNvPr id="13" name="Shape 11"/>
+          <p:cNvSpPr/>
+          <p:nvPr/>
+        </p:nvSpPr>
+        <p:spPr>
+          <a:xfrm>
+            <a:off x="4800600" y="2282952"/>
+            <a:ext cx="4069080" cy="1380744"/>
+          </a:xfrm>
+          <a:prstGeom prst="rect">
+            <a:avLst/>
+          </a:prstGeom>
+          <a:solidFill>
+            <a:srgbClr val="F2F4F8"/>
+          </a:solidFill>
+          <a:ln w="12700">
+            <a:solidFill>
+              <a:srgbClr val="F2F4F8"/>
+            </a:solidFill>
+            <a:prstDash val="solid"/>
+          </a:ln>
+        </p:spPr>
+        <p:txBody>
+          <a:bodyPr/>
+          <a:lstStyle/>
+          <a:p>
+            <a:endParaRPr lang="es-ES"/>
+          </a:p>
+        </p:txBody>
+      </p:sp>
+      <p:sp>
+        <p:nvSpPr>
+          <p:cNvPr id="14" name="Shape 12"/>
+          <p:cNvSpPr/>
+          <p:nvPr/>
+        </p:nvSpPr>
+        <p:spPr>
+          <a:xfrm>
+            <a:off x="4800600" y="2282952"/>
+            <a:ext cx="4069080" cy="64008"/>
+          </a:xfrm>
+          <a:prstGeom prst="rect">
+            <a:avLst/>
+          </a:prstGeom>
+          <a:solidFill>
+            <a:srgbClr val="1E8449"/>
+          </a:solidFill>
+          <a:ln w="12700">
+            <a:solidFill>
+              <a:srgbClr val="1E8449"/>
+            </a:solidFill>
+            <a:prstDash val="solid"/>
+          </a:ln>
+        </p:spPr>
+        <p:txBody>
+          <a:bodyPr/>
+          <a:lstStyle/>
+          <a:p>
+            <a:endParaRPr lang="es-ES"/>
+          </a:p>
+        </p:txBody>
+      </p:sp>
+      <p:sp>
+        <p:nvSpPr>
+          <p:cNvPr id="15" name="Text 13"/>
+          <p:cNvSpPr txBox="1"/>
+          <p:nvPr/>
+        </p:nvSpPr>
+        <p:spPr>
+          <a:xfrm>
+            <a:off x="4892040" y="2401824"/>
+            <a:ext cx="3886200" cy="347472"/>
+          </a:xfrm>
+          <a:prstGeom prst="rect">
+            <a:avLst/>
+          </a:prstGeom>
+          <a:noFill/>
+          <a:ln/>
+        </p:spPr>
+        <p:txBody>
+          <a:bodyPr wrap="square" rtlCol="0" anchor="ctr"/>
+          <a:lstStyle/>
+          <a:p>
+            <a:pPr marL="0" indent="0">
+              <a:buNone/>
+            </a:pPr>
+            <a:r>
+              <a:rPr lang="en-US" sz="1400" b="1" dirty="0">
+                <a:solidFill>
+                  <a:srgbClr val="1A1A2E"/>
+                </a:solidFill>
+              </a:rPr>
+              <a:t>¿Por qué T1DiabetesGranada es inconsistente?</a:t>
+            </a:r>
+            <a:endParaRPr lang="en-US" sz="1400" dirty="0"/>
+          </a:p>
+        </p:txBody>
+      </p:sp>
+      <p:sp>
+        <p:nvSpPr>
+          <p:cNvPr id="16" name="Text 14"/>
+          <p:cNvSpPr txBox="1"/>
+          <p:nvPr/>
+        </p:nvSpPr>
+        <p:spPr>
+          <a:xfrm>
+            <a:off x="4892040" y="2785872"/>
+            <a:ext cx="3886200" cy="781812"/>
+          </a:xfrm>
+          <a:prstGeom prst="rect">
+            <a:avLst/>
+          </a:prstGeom>
+          <a:noFill/>
+          <a:ln/>
+        </p:spPr>
+        <p:txBody>
+          <a:bodyPr wrap="square" rtlCol="0" anchor="ctr"/>
+          <a:lstStyle/>
+          <a:p>
+            <a:pPr marL="0" indent="0">
+              <a:buNone/>
+            </a:pPr>
+            <a:r>
+              <a:rPr lang="en-US" sz="1100" dirty="0">
+                <a:solidFill>
+                  <a:srgbClr val="1A1A2E"/>
+                </a:solidFill>
+              </a:rPr>
+              <a:t>La heterogeneidad fenotípica de 643 pacientes reales introduce una variabilidad inter-paciente que supera en todo momento la señal del desequilibrio demográfico. Cada fold asigna pacientes con perfiles glucémicos distintos.</a:t>
+            </a:r>
+            <a:endParaRPr lang="en-US" sz="1100" dirty="0"/>
+          </a:p>
+        </p:txBody>
+      </p:sp>
+      <p:sp>
+        <p:nvSpPr>
+          <p:cNvPr id="17" name="Shape 15"/>
+          <p:cNvSpPr/>
+          <p:nvPr/>
+        </p:nvSpPr>
+        <p:spPr>
+          <a:xfrm>
+            <a:off x="502920" y="3840480"/>
+            <a:ext cx="8138160" cy="749808"/>
+          </a:xfrm>
+          <a:prstGeom prst="rect">
+            <a:avLst/>
+          </a:prstGeom>
+          <a:solidFill>
+            <a:srgbClr val="EBF5FB"/>
+          </a:solidFill>
+          <a:ln w="12700">
+            <a:solidFill>
+              <a:srgbClr val="EBF5FB"/>
+            </a:solidFill>
+            <a:prstDash val="solid"/>
+          </a:ln>
+        </p:spPr>
+        <p:txBody>
+          <a:bodyPr/>
+          <a:lstStyle/>
+          <a:p>
+            <a:endParaRPr lang="es-ES"/>
+          </a:p>
+        </p:txBody>
+      </p:sp>
+      <p:sp>
+        <p:nvSpPr>
+          <p:cNvPr id="18" name="Shape 16"/>
+          <p:cNvSpPr/>
+          <p:nvPr/>
+        </p:nvSpPr>
+        <p:spPr>
+          <a:xfrm>
+            <a:off x="502920" y="3840480"/>
+            <a:ext cx="64008" cy="749808"/>
+          </a:xfrm>
+          <a:prstGeom prst="rect">
+            <a:avLst/>
+          </a:prstGeom>
+          <a:solidFill>
+            <a:srgbClr val="1B4F72"/>
+          </a:solidFill>
+          <a:ln w="12700">
+            <a:solidFill>
+              <a:srgbClr val="1B4F72"/>
+            </a:solidFill>
+            <a:prstDash val="solid"/>
+          </a:ln>
+        </p:spPr>
+        <p:txBody>
+          <a:bodyPr/>
+          <a:lstStyle/>
+          <a:p>
+            <a:endParaRPr lang="es-ES"/>
+          </a:p>
+        </p:txBody>
+      </p:sp>
+      <p:sp>
+        <p:nvSpPr>
+          <p:cNvPr id="19" name="Text 17"/>
+          <p:cNvSpPr txBox="1"/>
+          <p:nvPr/>
+        </p:nvSpPr>
+        <p:spPr>
+          <a:xfrm>
+            <a:off x="640080" y="3867912"/>
+            <a:ext cx="2743200" cy="256032"/>
+          </a:xfrm>
+          <a:prstGeom prst="rect">
+            <a:avLst/>
+          </a:prstGeom>
+          <a:noFill/>
+          <a:ln/>
+        </p:spPr>
+        <p:txBody>
+          <a:bodyPr wrap="square" rtlCol="0" anchor="ctr"/>
+          <a:lstStyle/>
+          <a:p>
+            <a:pPr marL="0" indent="0">
+              <a:buNone/>
+            </a:pPr>
+            <a:r>
+              <a:rPr lang="en-US" sz="1400" b="1" dirty="0">
+                <a:solidFill>
+                  <a:srgbClr val="1B4F72"/>
+                </a:solidFill>
+              </a:rPr>
+              <a:t>Corolario práctico</a:t>
+            </a:r>
+            <a:endParaRPr lang="en-US" sz="1400" dirty="0"/>
+          </a:p>
+        </p:txBody>
+      </p:sp>
+      <p:sp>
+        <p:nvSpPr>
+          <p:cNvPr id="20" name="Text 18"/>
+          <p:cNvSpPr txBox="1"/>
+          <p:nvPr/>
+        </p:nvSpPr>
+        <p:spPr>
+          <a:xfrm>
+            <a:off x="640080" y="4160520"/>
+            <a:ext cx="7909560" cy="384048"/>
+          </a:xfrm>
+          <a:prstGeom prst="rect">
+            <a:avLst/>
+          </a:prstGeom>
+          <a:noFill/>
+          <a:ln/>
+        </p:spPr>
+        <p:txBody>
+          <a:bodyPr wrap="square" rtlCol="0" anchor="ctr"/>
+          <a:lstStyle/>
+          <a:p>
+            <a:pPr marL="0" indent="0">
+              <a:buNone/>
+            </a:pPr>
+            <a:r>
+              <a:rPr lang="en-US" sz="1000" dirty="0">
+                <a:solidFill>
+                  <a:srgbClr val="1A1A2E"/>
+                </a:solidFill>
+              </a:rPr>
+              <a:t>La consistencia inter-fold (Spearman) no mide la calidad del pipeline, sino el régimen de varianza que domina el dataset. Un sesgo demográfico extremo produce rankings más estables que una cohorte rica, porque el sesgo es la señal dominante. En cohortes clínicas heterogéneas, la inconsistencia del ranking es el resultado esperado de una partición honesta.</a:t>
+            </a:r>
+            <a:endParaRPr lang="en-US" sz="1000" dirty="0"/>
+          </a:p>
+        </p:txBody>
+      </p:sp>
+      <p:sp>
+        <p:nvSpPr>
+          <p:cNvPr id="22" name="Shape 1">
+            <a:extLst>
+              <a:ext uri="{FF2B5EF4-FFF2-40B4-BE49-F238E27FC236}">
+                <a16:creationId xmlns:a16="http://schemas.microsoft.com/office/drawing/2014/main" id="{B3671E70-8FB2-9088-E68C-1C8C3E614954}"/>
+              </a:ext>
+            </a:extLst>
+          </p:cNvPr>
+          <p:cNvSpPr/>
+          <p:nvPr/>
+        </p:nvSpPr>
+        <p:spPr>
+          <a:xfrm>
+            <a:off x="502920" y="5070348"/>
             <a:ext cx="8138160" cy="27432"/>
           </a:xfrm>
           <a:prstGeom prst="rect">
@@ -2186,586 +2772,6 @@
           <a:lstStyle/>
           <a:p>
             <a:endParaRPr lang="es-ES"/>
-          </a:p>
-        </p:txBody>
-      </p:sp>
-      <p:sp>
-        <p:nvSpPr>
-          <p:cNvPr id="4" name="Text 2"/>
-          <p:cNvSpPr txBox="1"/>
-          <p:nvPr/>
-        </p:nvSpPr>
-        <p:spPr>
-          <a:xfrm>
-            <a:off x="8229600" y="4869180"/>
-            <a:ext cx="777240" cy="201168"/>
-          </a:xfrm>
-          <a:prstGeom prst="rect">
-            <a:avLst/>
-          </a:prstGeom>
-          <a:noFill/>
-          <a:ln/>
-        </p:spPr>
-        <p:txBody>
-          <a:bodyPr wrap="square" rtlCol="0" anchor="ctr"/>
-          <a:lstStyle/>
-          <a:p>
-            <a:pPr marL="0" indent="0" algn="r">
-              <a:buNone/>
-            </a:pPr>
-            <a:r>
-              <a:rPr lang="en-US" sz="1200" dirty="0">
-                <a:solidFill>
-                  <a:srgbClr val="7F8C8D"/>
-                </a:solidFill>
-              </a:rPr>
-              <a:t>10 / 12</a:t>
-            </a:r>
-            <a:endParaRPr lang="en-US" sz="1200" dirty="0"/>
-          </a:p>
-        </p:txBody>
-      </p:sp>
-      <p:sp>
-        <p:nvSpPr>
-          <p:cNvPr id="5" name="Shape 3"/>
-          <p:cNvSpPr/>
-          <p:nvPr/>
-        </p:nvSpPr>
-        <p:spPr>
-          <a:xfrm>
-            <a:off x="502920" y="1170432"/>
-            <a:ext cx="8138160" cy="685800"/>
-          </a:xfrm>
-          <a:prstGeom prst="rect">
-            <a:avLst/>
-          </a:prstGeom>
-          <a:solidFill>
-            <a:srgbClr val="FEF9E7"/>
-          </a:solidFill>
-          <a:ln w="12700">
-            <a:solidFill>
-              <a:srgbClr val="FEF9E7"/>
-            </a:solidFill>
-            <a:prstDash val="solid"/>
-          </a:ln>
-        </p:spPr>
-        <p:txBody>
-          <a:bodyPr/>
-          <a:lstStyle/>
-          <a:p>
-            <a:endParaRPr lang="es-ES"/>
-          </a:p>
-        </p:txBody>
-      </p:sp>
-      <p:sp>
-        <p:nvSpPr>
-          <p:cNvPr id="6" name="Shape 4"/>
-          <p:cNvSpPr/>
-          <p:nvPr/>
-        </p:nvSpPr>
-        <p:spPr>
-          <a:xfrm>
-            <a:off x="502920" y="1170432"/>
-            <a:ext cx="64008" cy="685800"/>
-          </a:xfrm>
-          <a:prstGeom prst="rect">
-            <a:avLst/>
-          </a:prstGeom>
-          <a:solidFill>
-            <a:srgbClr val="E67E22"/>
-          </a:solidFill>
-          <a:ln w="12700">
-            <a:solidFill>
-              <a:srgbClr val="E67E22"/>
-            </a:solidFill>
-            <a:prstDash val="solid"/>
-          </a:ln>
-        </p:spPr>
-        <p:txBody>
-          <a:bodyPr/>
-          <a:lstStyle/>
-          <a:p>
-            <a:endParaRPr lang="es-ES"/>
-          </a:p>
-        </p:txBody>
-      </p:sp>
-      <p:sp>
-        <p:nvSpPr>
-          <p:cNvPr id="7" name="Text 5"/>
-          <p:cNvSpPr txBox="1"/>
-          <p:nvPr/>
-        </p:nvSpPr>
-        <p:spPr>
-          <a:xfrm>
-            <a:off x="640080" y="1188720"/>
-            <a:ext cx="3657600" cy="256032"/>
-          </a:xfrm>
-          <a:prstGeom prst="rect">
-            <a:avLst/>
-          </a:prstGeom>
-          <a:noFill/>
-          <a:ln/>
-        </p:spPr>
-        <p:txBody>
-          <a:bodyPr wrap="square" rtlCol="0" anchor="ctr"/>
-          <a:lstStyle/>
-          <a:p>
-            <a:pPr marL="0" indent="0">
-              <a:buNone/>
-            </a:pPr>
-            <a:r>
-              <a:rPr lang="en-US" sz="1400" b="1" dirty="0">
-                <a:solidFill>
-                  <a:srgbClr val="E67E22"/>
-                </a:solidFill>
-              </a:rPr>
-              <a:t>La paradoja observada</a:t>
-            </a:r>
-            <a:endParaRPr lang="en-US" sz="1400" dirty="0"/>
-          </a:p>
-        </p:txBody>
-      </p:sp>
-      <p:sp>
-        <p:nvSpPr>
-          <p:cNvPr id="8" name="Text 6"/>
-          <p:cNvSpPr txBox="1"/>
-          <p:nvPr/>
-        </p:nvSpPr>
-        <p:spPr>
-          <a:xfrm>
-            <a:off x="640080" y="1463040"/>
-            <a:ext cx="7909560" cy="347472"/>
-          </a:xfrm>
-          <a:prstGeom prst="rect">
-            <a:avLst/>
-          </a:prstGeom>
-          <a:noFill/>
-          <a:ln/>
-        </p:spPr>
-        <p:txBody>
-          <a:bodyPr wrap="square" rtlCol="0" anchor="ctr"/>
-          <a:lstStyle/>
-          <a:p>
-            <a:pPr marL="0" indent="0">
-              <a:buNone/>
-            </a:pPr>
-            <a:r>
-              <a:rPr lang="en-US" sz="1100" dirty="0">
-                <a:solidFill>
-                  <a:srgbClr val="1A1A2E"/>
-                </a:solidFill>
-              </a:rPr>
-              <a:t>El dataset más pequeño (DiaTrend, 51 pac.) produce los rankings de técnicas más consistentes entre folds (Spearman &gt; 0,78). El dataset más grande (T1DiabetesGranada, 643 pac.) produce los rankings menos reproducibles (Spearman ≈ 0,01–0,36).</a:t>
-            </a:r>
-            <a:endParaRPr lang="en-US" sz="1100" dirty="0"/>
-          </a:p>
-        </p:txBody>
-      </p:sp>
-      <p:sp>
-        <p:nvSpPr>
-          <p:cNvPr id="9" name="Shape 7"/>
-          <p:cNvSpPr/>
-          <p:nvPr/>
-        </p:nvSpPr>
-        <p:spPr>
-          <a:xfrm>
-            <a:off x="502920" y="2282952"/>
-            <a:ext cx="4069080" cy="1380744"/>
-          </a:xfrm>
-          <a:prstGeom prst="rect">
-            <a:avLst/>
-          </a:prstGeom>
-          <a:solidFill>
-            <a:srgbClr val="F2F4F8"/>
-          </a:solidFill>
-          <a:ln w="12700">
-            <a:solidFill>
-              <a:srgbClr val="F2F4F8"/>
-            </a:solidFill>
-            <a:prstDash val="solid"/>
-          </a:ln>
-        </p:spPr>
-        <p:txBody>
-          <a:bodyPr/>
-          <a:lstStyle/>
-          <a:p>
-            <a:endParaRPr lang="es-ES"/>
-          </a:p>
-        </p:txBody>
-      </p:sp>
-      <p:sp>
-        <p:nvSpPr>
-          <p:cNvPr id="10" name="Shape 8"/>
-          <p:cNvSpPr/>
-          <p:nvPr/>
-        </p:nvSpPr>
-        <p:spPr>
-          <a:xfrm>
-            <a:off x="502920" y="2282952"/>
-            <a:ext cx="4069080" cy="64008"/>
-          </a:xfrm>
-          <a:prstGeom prst="rect">
-            <a:avLst/>
-          </a:prstGeom>
-          <a:solidFill>
-            <a:srgbClr val="1B4F72"/>
-          </a:solidFill>
-          <a:ln w="12700">
-            <a:solidFill>
-              <a:srgbClr val="1B4F72"/>
-            </a:solidFill>
-            <a:prstDash val="solid"/>
-          </a:ln>
-        </p:spPr>
-        <p:txBody>
-          <a:bodyPr/>
-          <a:lstStyle/>
-          <a:p>
-            <a:endParaRPr lang="es-ES"/>
-          </a:p>
-        </p:txBody>
-      </p:sp>
-      <p:sp>
-        <p:nvSpPr>
-          <p:cNvPr id="11" name="Text 9"/>
-          <p:cNvSpPr txBox="1"/>
-          <p:nvPr/>
-        </p:nvSpPr>
-        <p:spPr>
-          <a:xfrm>
-            <a:off x="594360" y="2401824"/>
-            <a:ext cx="3886200" cy="347472"/>
-          </a:xfrm>
-          <a:prstGeom prst="rect">
-            <a:avLst/>
-          </a:prstGeom>
-          <a:noFill/>
-          <a:ln/>
-        </p:spPr>
-        <p:txBody>
-          <a:bodyPr wrap="square" rtlCol="0" anchor="ctr"/>
-          <a:lstStyle/>
-          <a:p>
-            <a:pPr marL="0" indent="0">
-              <a:buNone/>
-            </a:pPr>
-            <a:r>
-              <a:rPr lang="en-US" sz="1400" b="1" dirty="0">
-                <a:solidFill>
-                  <a:srgbClr val="1A1A2E"/>
-                </a:solidFill>
-              </a:rPr>
-              <a:t>¿Por qué DiaTrend es consistente?</a:t>
-            </a:r>
-            <a:endParaRPr lang="en-US" sz="1400" dirty="0"/>
-          </a:p>
-        </p:txBody>
-      </p:sp>
-      <p:sp>
-        <p:nvSpPr>
-          <p:cNvPr id="12" name="Text 10"/>
-          <p:cNvSpPr txBox="1"/>
-          <p:nvPr/>
-        </p:nvSpPr>
-        <p:spPr>
-          <a:xfrm>
-            <a:off x="594360" y="2759964"/>
-            <a:ext cx="3886200" cy="844296"/>
-          </a:xfrm>
-          <a:prstGeom prst="rect">
-            <a:avLst/>
-          </a:prstGeom>
-          <a:noFill/>
-          <a:ln/>
-        </p:spPr>
-        <p:txBody>
-          <a:bodyPr wrap="square" rtlCol="0" anchor="ctr"/>
-          <a:lstStyle/>
-          <a:p>
-            <a:pPr marL="0" indent="0">
-              <a:buNone/>
-            </a:pPr>
-            <a:r>
-              <a:rPr lang="en-US" sz="1100" dirty="0">
-                <a:solidFill>
-                  <a:srgbClr val="1A1A2E"/>
-                </a:solidFill>
-              </a:rPr>
-              <a:t>El desequilibrio extremo (38:1 por edad) actúa como señal dominante de varianza. El sesgo gobierna el comportamiento del optimizador de forma idéntica en todos los folds, independientemente de qué pacientes concretos los componen.</a:t>
-            </a:r>
-            <a:endParaRPr lang="en-US" sz="1100" dirty="0"/>
-          </a:p>
-        </p:txBody>
-      </p:sp>
-      <p:sp>
-        <p:nvSpPr>
-          <p:cNvPr id="13" name="Shape 11"/>
-          <p:cNvSpPr/>
-          <p:nvPr/>
-        </p:nvSpPr>
-        <p:spPr>
-          <a:xfrm>
-            <a:off x="4800600" y="2282952"/>
-            <a:ext cx="4069080" cy="1380744"/>
-          </a:xfrm>
-          <a:prstGeom prst="rect">
-            <a:avLst/>
-          </a:prstGeom>
-          <a:solidFill>
-            <a:srgbClr val="F2F4F8"/>
-          </a:solidFill>
-          <a:ln w="12700">
-            <a:solidFill>
-              <a:srgbClr val="F2F4F8"/>
-            </a:solidFill>
-            <a:prstDash val="solid"/>
-          </a:ln>
-        </p:spPr>
-        <p:txBody>
-          <a:bodyPr/>
-          <a:lstStyle/>
-          <a:p>
-            <a:endParaRPr lang="es-ES"/>
-          </a:p>
-        </p:txBody>
-      </p:sp>
-      <p:sp>
-        <p:nvSpPr>
-          <p:cNvPr id="14" name="Shape 12"/>
-          <p:cNvSpPr/>
-          <p:nvPr/>
-        </p:nvSpPr>
-        <p:spPr>
-          <a:xfrm>
-            <a:off x="4800600" y="2282952"/>
-            <a:ext cx="4069080" cy="64008"/>
-          </a:xfrm>
-          <a:prstGeom prst="rect">
-            <a:avLst/>
-          </a:prstGeom>
-          <a:solidFill>
-            <a:srgbClr val="1E8449"/>
-          </a:solidFill>
-          <a:ln w="12700">
-            <a:solidFill>
-              <a:srgbClr val="1E8449"/>
-            </a:solidFill>
-            <a:prstDash val="solid"/>
-          </a:ln>
-        </p:spPr>
-        <p:txBody>
-          <a:bodyPr/>
-          <a:lstStyle/>
-          <a:p>
-            <a:endParaRPr lang="es-ES"/>
-          </a:p>
-        </p:txBody>
-      </p:sp>
-      <p:sp>
-        <p:nvSpPr>
-          <p:cNvPr id="15" name="Text 13"/>
-          <p:cNvSpPr txBox="1"/>
-          <p:nvPr/>
-        </p:nvSpPr>
-        <p:spPr>
-          <a:xfrm>
-            <a:off x="4892040" y="2401824"/>
-            <a:ext cx="3886200" cy="347472"/>
-          </a:xfrm>
-          <a:prstGeom prst="rect">
-            <a:avLst/>
-          </a:prstGeom>
-          <a:noFill/>
-          <a:ln/>
-        </p:spPr>
-        <p:txBody>
-          <a:bodyPr wrap="square" rtlCol="0" anchor="ctr"/>
-          <a:lstStyle/>
-          <a:p>
-            <a:pPr marL="0" indent="0">
-              <a:buNone/>
-            </a:pPr>
-            <a:r>
-              <a:rPr lang="en-US" sz="1400" b="1" dirty="0">
-                <a:solidFill>
-                  <a:srgbClr val="1A1A2E"/>
-                </a:solidFill>
-              </a:rPr>
-              <a:t>¿Por qué T1DiabetesGranada es inconsistente?</a:t>
-            </a:r>
-            <a:endParaRPr lang="en-US" sz="1400" dirty="0"/>
-          </a:p>
-        </p:txBody>
-      </p:sp>
-      <p:sp>
-        <p:nvSpPr>
-          <p:cNvPr id="16" name="Text 14"/>
-          <p:cNvSpPr txBox="1"/>
-          <p:nvPr/>
-        </p:nvSpPr>
-        <p:spPr>
-          <a:xfrm>
-            <a:off x="4892040" y="2785872"/>
-            <a:ext cx="3886200" cy="781812"/>
-          </a:xfrm>
-          <a:prstGeom prst="rect">
-            <a:avLst/>
-          </a:prstGeom>
-          <a:noFill/>
-          <a:ln/>
-        </p:spPr>
-        <p:txBody>
-          <a:bodyPr wrap="square" rtlCol="0" anchor="ctr"/>
-          <a:lstStyle/>
-          <a:p>
-            <a:pPr marL="0" indent="0">
-              <a:buNone/>
-            </a:pPr>
-            <a:r>
-              <a:rPr lang="en-US" sz="1100" dirty="0">
-                <a:solidFill>
-                  <a:srgbClr val="1A1A2E"/>
-                </a:solidFill>
-              </a:rPr>
-              <a:t>La heterogeneidad fenotípica de 643 pacientes reales introduce una variabilidad inter-paciente que supera en todo momento la señal del desequilibrio demográfico. Cada fold asigna pacientes con perfiles glucémicos distintos.</a:t>
-            </a:r>
-            <a:endParaRPr lang="en-US" sz="1100" dirty="0"/>
-          </a:p>
-        </p:txBody>
-      </p:sp>
-      <p:sp>
-        <p:nvSpPr>
-          <p:cNvPr id="17" name="Shape 15"/>
-          <p:cNvSpPr/>
-          <p:nvPr/>
-        </p:nvSpPr>
-        <p:spPr>
-          <a:xfrm>
-            <a:off x="502920" y="3840480"/>
-            <a:ext cx="8138160" cy="749808"/>
-          </a:xfrm>
-          <a:prstGeom prst="rect">
-            <a:avLst/>
-          </a:prstGeom>
-          <a:solidFill>
-            <a:srgbClr val="EBF5FB"/>
-          </a:solidFill>
-          <a:ln w="12700">
-            <a:solidFill>
-              <a:srgbClr val="EBF5FB"/>
-            </a:solidFill>
-            <a:prstDash val="solid"/>
-          </a:ln>
-        </p:spPr>
-        <p:txBody>
-          <a:bodyPr/>
-          <a:lstStyle/>
-          <a:p>
-            <a:endParaRPr lang="es-ES"/>
-          </a:p>
-        </p:txBody>
-      </p:sp>
-      <p:sp>
-        <p:nvSpPr>
-          <p:cNvPr id="18" name="Shape 16"/>
-          <p:cNvSpPr/>
-          <p:nvPr/>
-        </p:nvSpPr>
-        <p:spPr>
-          <a:xfrm>
-            <a:off x="502920" y="3840480"/>
-            <a:ext cx="64008" cy="749808"/>
-          </a:xfrm>
-          <a:prstGeom prst="rect">
-            <a:avLst/>
-          </a:prstGeom>
-          <a:solidFill>
-            <a:srgbClr val="1B4F72"/>
-          </a:solidFill>
-          <a:ln w="12700">
-            <a:solidFill>
-              <a:srgbClr val="1B4F72"/>
-            </a:solidFill>
-            <a:prstDash val="solid"/>
-          </a:ln>
-        </p:spPr>
-        <p:txBody>
-          <a:bodyPr/>
-          <a:lstStyle/>
-          <a:p>
-            <a:endParaRPr lang="es-ES"/>
-          </a:p>
-        </p:txBody>
-      </p:sp>
-      <p:sp>
-        <p:nvSpPr>
-          <p:cNvPr id="19" name="Text 17"/>
-          <p:cNvSpPr txBox="1"/>
-          <p:nvPr/>
-        </p:nvSpPr>
-        <p:spPr>
-          <a:xfrm>
-            <a:off x="640080" y="3867912"/>
-            <a:ext cx="2743200" cy="256032"/>
-          </a:xfrm>
-          <a:prstGeom prst="rect">
-            <a:avLst/>
-          </a:prstGeom>
-          <a:noFill/>
-          <a:ln/>
-        </p:spPr>
-        <p:txBody>
-          <a:bodyPr wrap="square" rtlCol="0" anchor="ctr"/>
-          <a:lstStyle/>
-          <a:p>
-            <a:pPr marL="0" indent="0">
-              <a:buNone/>
-            </a:pPr>
-            <a:r>
-              <a:rPr lang="en-US" sz="1400" b="1" dirty="0">
-                <a:solidFill>
-                  <a:srgbClr val="1B4F72"/>
-                </a:solidFill>
-              </a:rPr>
-              <a:t>Corolario práctico</a:t>
-            </a:r>
-            <a:endParaRPr lang="en-US" sz="1400" dirty="0"/>
-          </a:p>
-        </p:txBody>
-      </p:sp>
-      <p:sp>
-        <p:nvSpPr>
-          <p:cNvPr id="20" name="Text 18"/>
-          <p:cNvSpPr txBox="1"/>
-          <p:nvPr/>
-        </p:nvSpPr>
-        <p:spPr>
-          <a:xfrm>
-            <a:off x="640080" y="4160520"/>
-            <a:ext cx="7909560" cy="384048"/>
-          </a:xfrm>
-          <a:prstGeom prst="rect">
-            <a:avLst/>
-          </a:prstGeom>
-          <a:noFill/>
-          <a:ln/>
-        </p:spPr>
-        <p:txBody>
-          <a:bodyPr wrap="square" rtlCol="0" anchor="ctr"/>
-          <a:lstStyle/>
-          <a:p>
-            <a:pPr marL="0" indent="0">
-              <a:buNone/>
-            </a:pPr>
-            <a:r>
-              <a:rPr lang="en-US" sz="1000" dirty="0">
-                <a:solidFill>
-                  <a:srgbClr val="1A1A2E"/>
-                </a:solidFill>
-              </a:rPr>
-              <a:t>La consistencia inter-fold (Spearman) no mide la calidad del pipeline, sino el régimen de varianza que domina el dataset. Un sesgo demográfico extremo produce rankings más estables que una cohorte rica, porque el sesgo es la señal dominante. En cohortes clínicas heterogéneas, la inconsistencia del ranking es el resultado esperado de una partición honesta.</a:t>
-            </a:r>
-            <a:endParaRPr lang="en-US" sz="1000" dirty="0"/>
           </a:p>
         </p:txBody>
       </p:sp>
@@ -5036,14 +5042,14 @@
               <a:buNone/>
             </a:pPr>
             <a:r>
-              <a:rPr lang="en-US" sz="3200" b="1" dirty="0">
+              <a:rPr lang="en-US" sz="2800" b="1" dirty="0">
                 <a:solidFill>
                   <a:srgbClr val="1A1A2E"/>
                 </a:solidFill>
               </a:rPr>
               <a:t>¿El modelo trata igual a todos los pacientes?</a:t>
             </a:r>
-            <a:endParaRPr lang="en-US" sz="3200" dirty="0"/>
+            <a:endParaRPr lang="en-US" sz="2800" dirty="0"/>
           </a:p>
         </p:txBody>
       </p:sp>
@@ -5055,7 +5061,7 @@
         </p:nvSpPr>
         <p:spPr>
           <a:xfrm>
-            <a:off x="502920" y="4802124"/>
+            <a:off x="502920" y="5076444"/>
             <a:ext cx="8138160" cy="27432"/>
           </a:xfrm>
           <a:prstGeom prst="rect">
@@ -5812,6 +5818,44 @@
               <a:t>¿Mejora el balanceo demográfico del conjunto de entrenamiento el rendimiento clínico de un modelo LSTM, especialmente para subgrupos minoritarios?</a:t>
             </a:r>
             <a:endParaRPr lang="en-US" sz="1100" dirty="0"/>
+          </a:p>
+        </p:txBody>
+      </p:sp>
+      <p:sp>
+        <p:nvSpPr>
+          <p:cNvPr id="24" name="Shape 1">
+            <a:extLst>
+              <a:ext uri="{FF2B5EF4-FFF2-40B4-BE49-F238E27FC236}">
+                <a16:creationId xmlns:a16="http://schemas.microsoft.com/office/drawing/2014/main" id="{77DC9C70-A070-8072-3EED-A767F799F04A}"/>
+              </a:ext>
+            </a:extLst>
+          </p:cNvPr>
+          <p:cNvSpPr/>
+          <p:nvPr/>
+        </p:nvSpPr>
+        <p:spPr>
+          <a:xfrm>
+            <a:off x="502920" y="5070348"/>
+            <a:ext cx="8138160" cy="27432"/>
+          </a:xfrm>
+          <a:prstGeom prst="rect">
+            <a:avLst/>
+          </a:prstGeom>
+          <a:solidFill>
+            <a:srgbClr val="BDC3C7"/>
+          </a:solidFill>
+          <a:ln w="12700">
+            <a:solidFill>
+              <a:srgbClr val="BDC3C7"/>
+            </a:solidFill>
+            <a:prstDash val="solid"/>
+          </a:ln>
+        </p:spPr>
+        <p:txBody>
+          <a:bodyPr/>
+          <a:lstStyle/>
+          <a:p>
+            <a:endParaRPr lang="es-ES"/>
           </a:p>
         </p:txBody>
       </p:sp>
@@ -9248,38 +9292,6 @@
       </p:sp>
       <p:sp>
         <p:nvSpPr>
-          <p:cNvPr id="3" name="Shape 1"/>
-          <p:cNvSpPr/>
-          <p:nvPr/>
-        </p:nvSpPr>
-        <p:spPr>
-          <a:xfrm>
-            <a:off x="332232" y="5070348"/>
-            <a:ext cx="8138160" cy="27432"/>
-          </a:xfrm>
-          <a:prstGeom prst="rect">
-            <a:avLst/>
-          </a:prstGeom>
-          <a:solidFill>
-            <a:srgbClr val="BDC3C7"/>
-          </a:solidFill>
-          <a:ln w="12700">
-            <a:solidFill>
-              <a:srgbClr val="BDC3C7"/>
-            </a:solidFill>
-            <a:prstDash val="solid"/>
-          </a:ln>
-        </p:spPr>
-        <p:txBody>
-          <a:bodyPr/>
-          <a:lstStyle/>
-          <a:p>
-            <a:endParaRPr lang="es-ES"/>
-          </a:p>
-        </p:txBody>
-      </p:sp>
-      <p:sp>
-        <p:nvSpPr>
           <p:cNvPr id="4" name="Text 2"/>
           <p:cNvSpPr txBox="1"/>
           <p:nvPr/>
@@ -10546,6 +10558,44 @@
           </a:fontRef>
         </p:style>
       </p:cxnSp>
+      <p:sp>
+        <p:nvSpPr>
+          <p:cNvPr id="40" name="Shape 1">
+            <a:extLst>
+              <a:ext uri="{FF2B5EF4-FFF2-40B4-BE49-F238E27FC236}">
+                <a16:creationId xmlns:a16="http://schemas.microsoft.com/office/drawing/2014/main" id="{462C1E63-8F70-6231-3EE0-E8D5E250E659}"/>
+              </a:ext>
+            </a:extLst>
+          </p:cNvPr>
+          <p:cNvSpPr/>
+          <p:nvPr/>
+        </p:nvSpPr>
+        <p:spPr>
+          <a:xfrm>
+            <a:off x="502920" y="5070348"/>
+            <a:ext cx="8138160" cy="27432"/>
+          </a:xfrm>
+          <a:prstGeom prst="rect">
+            <a:avLst/>
+          </a:prstGeom>
+          <a:solidFill>
+            <a:srgbClr val="BDC3C7"/>
+          </a:solidFill>
+          <a:ln w="12700">
+            <a:solidFill>
+              <a:srgbClr val="BDC3C7"/>
+            </a:solidFill>
+            <a:prstDash val="solid"/>
+          </a:ln>
+        </p:spPr>
+        <p:txBody>
+          <a:bodyPr/>
+          <a:lstStyle/>
+          <a:p>
+            <a:endParaRPr lang="es-ES"/>
+          </a:p>
+        </p:txBody>
+      </p:sp>
     </p:spTree>
   </p:cSld>
   <p:clrMapOvr>
@@ -11091,7 +11141,7 @@
         </p:nvSpPr>
         <p:spPr>
           <a:xfrm>
-            <a:off x="502920" y="1170432"/>
+            <a:off x="502920" y="1542731"/>
             <a:ext cx="5486400" cy="256032"/>
           </a:xfrm>
           <a:prstGeom prst="rect">
@@ -11127,7 +11177,7 @@
         </p:nvSpPr>
         <p:spPr>
           <a:xfrm>
-            <a:off x="502920" y="1508760"/>
+            <a:off x="502920" y="1796147"/>
             <a:ext cx="8138160" cy="475488"/>
           </a:xfrm>
           <a:prstGeom prst="rect">
@@ -11159,7 +11209,7 @@
         </p:nvSpPr>
         <p:spPr>
           <a:xfrm>
-            <a:off x="630936" y="1581912"/>
+            <a:off x="630936" y="1954211"/>
             <a:ext cx="1371600" cy="329184"/>
           </a:xfrm>
           <a:prstGeom prst="rect">
@@ -11195,7 +11245,7 @@
         </p:nvSpPr>
         <p:spPr>
           <a:xfrm>
-            <a:off x="2221992" y="1581912"/>
+            <a:off x="2221992" y="1954211"/>
             <a:ext cx="1371600" cy="329184"/>
           </a:xfrm>
           <a:prstGeom prst="rect">
@@ -11231,7 +11281,7 @@
         </p:nvSpPr>
         <p:spPr>
           <a:xfrm>
-            <a:off x="3249168" y="1581912"/>
+            <a:off x="3249168" y="1954211"/>
             <a:ext cx="1645920" cy="329184"/>
           </a:xfrm>
           <a:prstGeom prst="rect">
@@ -11267,7 +11317,7 @@
         </p:nvSpPr>
         <p:spPr>
           <a:xfrm>
-            <a:off x="502920" y="2057400"/>
+            <a:off x="502920" y="2344787"/>
             <a:ext cx="8138160" cy="475488"/>
           </a:xfrm>
           <a:prstGeom prst="rect">
@@ -11299,8 +11349,8 @@
         </p:nvSpPr>
         <p:spPr>
           <a:xfrm>
-            <a:off x="502920" y="2057400"/>
-            <a:ext cx="64008" cy="475488"/>
+            <a:off x="502920" y="2429699"/>
+            <a:ext cx="64008" cy="580644"/>
           </a:xfrm>
           <a:prstGeom prst="rect">
             <a:avLst/>
@@ -11331,7 +11381,7 @@
         </p:nvSpPr>
         <p:spPr>
           <a:xfrm>
-            <a:off x="630936" y="2130552"/>
+            <a:off x="630936" y="2502851"/>
             <a:ext cx="1371600" cy="329184"/>
           </a:xfrm>
           <a:prstGeom prst="rect">
@@ -11367,7 +11417,7 @@
         </p:nvSpPr>
         <p:spPr>
           <a:xfrm>
-            <a:off x="2221992" y="2130552"/>
+            <a:off x="2221992" y="2502851"/>
             <a:ext cx="1371600" cy="329184"/>
           </a:xfrm>
           <a:prstGeom prst="rect">
@@ -11403,7 +11453,7 @@
         </p:nvSpPr>
         <p:spPr>
           <a:xfrm>
-            <a:off x="3249168" y="2130552"/>
+            <a:off x="3249168" y="2502851"/>
             <a:ext cx="1645920" cy="329184"/>
           </a:xfrm>
           <a:prstGeom prst="rect">
@@ -11439,7 +11489,7 @@
         </p:nvSpPr>
         <p:spPr>
           <a:xfrm>
-            <a:off x="502920" y="2606040"/>
+            <a:off x="502920" y="2893427"/>
             <a:ext cx="8138160" cy="475488"/>
           </a:xfrm>
           <a:prstGeom prst="rect">
@@ -11471,7 +11521,7 @@
         </p:nvSpPr>
         <p:spPr>
           <a:xfrm>
-            <a:off x="502920" y="2606040"/>
+            <a:off x="502920" y="2978339"/>
             <a:ext cx="64008" cy="475488"/>
           </a:xfrm>
           <a:prstGeom prst="rect">
@@ -11503,7 +11553,7 @@
         </p:nvSpPr>
         <p:spPr>
           <a:xfrm>
-            <a:off x="630936" y="2679192"/>
+            <a:off x="630936" y="3051491"/>
             <a:ext cx="1371600" cy="329184"/>
           </a:xfrm>
           <a:prstGeom prst="rect">
@@ -11539,7 +11589,7 @@
         </p:nvSpPr>
         <p:spPr>
           <a:xfrm>
-            <a:off x="2221992" y="2679192"/>
+            <a:off x="2221992" y="3051491"/>
             <a:ext cx="1371600" cy="329184"/>
           </a:xfrm>
           <a:prstGeom prst="rect">
@@ -11575,7 +11625,7 @@
         </p:nvSpPr>
         <p:spPr>
           <a:xfrm>
-            <a:off x="3249168" y="2679192"/>
+            <a:off x="3249168" y="3051491"/>
             <a:ext cx="1645920" cy="329184"/>
           </a:xfrm>
           <a:prstGeom prst="rect">
@@ -11611,7 +11661,7 @@
         </p:nvSpPr>
         <p:spPr>
           <a:xfrm>
-            <a:off x="502920" y="3154680"/>
+            <a:off x="502920" y="3442067"/>
             <a:ext cx="8138160" cy="475488"/>
           </a:xfrm>
           <a:prstGeom prst="rect">
@@ -11643,7 +11693,7 @@
         </p:nvSpPr>
         <p:spPr>
           <a:xfrm>
-            <a:off x="630936" y="3227832"/>
+            <a:off x="630936" y="3600131"/>
             <a:ext cx="1295400" cy="329184"/>
           </a:xfrm>
           <a:prstGeom prst="rect">
@@ -11679,7 +11729,7 @@
         </p:nvSpPr>
         <p:spPr>
           <a:xfrm>
-            <a:off x="2221992" y="3227832"/>
+            <a:off x="2221992" y="3600131"/>
             <a:ext cx="1371600" cy="329184"/>
           </a:xfrm>
           <a:prstGeom prst="rect">
@@ -11715,7 +11765,7 @@
         </p:nvSpPr>
         <p:spPr>
           <a:xfrm>
-            <a:off x="3249168" y="3227832"/>
+            <a:off x="3249168" y="3600131"/>
             <a:ext cx="1645920" cy="329184"/>
           </a:xfrm>
           <a:prstGeom prst="rect">
@@ -11740,42 +11790,6 @@
               <a:t>p = 0,140</a:t>
             </a:r>
             <a:endParaRPr lang="en-US" sz="1000" dirty="0"/>
-          </a:p>
-        </p:txBody>
-      </p:sp>
-      <p:sp>
-        <p:nvSpPr>
-          <p:cNvPr id="28" name="Text 26"/>
-          <p:cNvSpPr txBox="1"/>
-          <p:nvPr/>
-        </p:nvSpPr>
-        <p:spPr>
-          <a:xfrm>
-            <a:off x="502920" y="3730752"/>
-            <a:ext cx="4227816" cy="131216"/>
-          </a:xfrm>
-          <a:prstGeom prst="rect">
-            <a:avLst/>
-          </a:prstGeom>
-          <a:noFill/>
-          <a:ln/>
-        </p:spPr>
-        <p:txBody>
-          <a:bodyPr wrap="square" rtlCol="0" anchor="ctr"/>
-          <a:lstStyle/>
-          <a:p>
-            <a:pPr marL="0" indent="0">
-              <a:buNone/>
-            </a:pPr>
-            <a:r>
-              <a:rPr lang="en-US" sz="1050" b="1" dirty="0">
-                <a:solidFill>
-                  <a:srgbClr val="1A1A2E"/>
-                </a:solidFill>
-              </a:rPr>
-              <a:t>Ranking Borda (agregación multicriterio)</a:t>
-            </a:r>
-            <a:endParaRPr lang="en-US" sz="1050" dirty="0"/>
           </a:p>
         </p:txBody>
       </p:sp>
@@ -11787,7 +11801,7 @@
         </p:nvSpPr>
         <p:spPr>
           <a:xfrm>
-            <a:off x="502920" y="4041648"/>
+            <a:off x="502920" y="4329035"/>
             <a:ext cx="7525512" cy="187452"/>
           </a:xfrm>
           <a:prstGeom prst="rect">
@@ -11813,121 +11827,13 @@
       </p:sp>
       <p:sp>
         <p:nvSpPr>
-          <p:cNvPr id="32" name="Text 30"/>
-          <p:cNvSpPr txBox="1"/>
-          <p:nvPr/>
-        </p:nvSpPr>
-        <p:spPr>
-          <a:xfrm>
-            <a:off x="868680" y="4096512"/>
-            <a:ext cx="2113908" cy="140589"/>
-          </a:xfrm>
-          <a:prstGeom prst="rect">
-            <a:avLst/>
-          </a:prstGeom>
-          <a:noFill/>
-          <a:ln/>
-        </p:spPr>
-        <p:txBody>
-          <a:bodyPr wrap="square" rtlCol="0" anchor="ctr"/>
-          <a:lstStyle/>
-          <a:p>
-            <a:pPr marL="0" indent="0">
-              <a:buNone/>
-            </a:pPr>
-            <a:r>
-              <a:rPr lang="en-US" sz="1000" b="1" dirty="0">
-                <a:solidFill>
-                  <a:srgbClr val="1A1A2E"/>
-                </a:solidFill>
-              </a:rPr>
-              <a:t>Tomek Links (edad)</a:t>
-            </a:r>
-            <a:endParaRPr lang="en-US" sz="1000" dirty="0"/>
-          </a:p>
-        </p:txBody>
-      </p:sp>
-      <p:sp>
-        <p:nvSpPr>
-          <p:cNvPr id="33" name="Text 31"/>
-          <p:cNvSpPr txBox="1"/>
-          <p:nvPr/>
-        </p:nvSpPr>
-        <p:spPr>
-          <a:xfrm>
-            <a:off x="2636520" y="4096512"/>
-            <a:ext cx="1691126" cy="140589"/>
-          </a:xfrm>
-          <a:prstGeom prst="rect">
-            <a:avLst/>
-          </a:prstGeom>
-          <a:noFill/>
-          <a:ln/>
-        </p:spPr>
-        <p:txBody>
-          <a:bodyPr wrap="square" rtlCol="0" anchor="ctr"/>
-          <a:lstStyle/>
-          <a:p>
-            <a:pPr marL="0" indent="0">
-              <a:buNone/>
-            </a:pPr>
-            <a:r>
-              <a:rPr lang="en-US" sz="1000" dirty="0">
-                <a:solidFill>
-                  <a:srgbClr val="7F8C8D"/>
-                </a:solidFill>
-              </a:rPr>
-              <a:t>(DiaTrend)</a:t>
-            </a:r>
-            <a:endParaRPr lang="en-US" sz="1000" dirty="0"/>
-          </a:p>
-        </p:txBody>
-      </p:sp>
-      <p:sp>
-        <p:nvSpPr>
-          <p:cNvPr id="34" name="Text 32"/>
-          <p:cNvSpPr txBox="1"/>
-          <p:nvPr/>
-        </p:nvSpPr>
-        <p:spPr>
-          <a:xfrm>
-            <a:off x="4389120" y="4096512"/>
-            <a:ext cx="3213140" cy="140589"/>
-          </a:xfrm>
-          <a:prstGeom prst="rect">
-            <a:avLst/>
-          </a:prstGeom>
-          <a:noFill/>
-          <a:ln/>
-        </p:spPr>
-        <p:txBody>
-          <a:bodyPr wrap="square" rtlCol="0" anchor="ctr"/>
-          <a:lstStyle/>
-          <a:p>
-            <a:pPr marL="0" indent="0">
-              <a:buNone/>
-            </a:pPr>
-            <a:r>
-              <a:rPr lang="en-US" sz="1000" dirty="0">
-                <a:solidFill>
-                  <a:srgbClr val="1A1A2E"/>
-                </a:solidFill>
-              </a:rPr>
-              <a:t>Mejor RMSE global (44,83) + sin deterioro TBR-2</a:t>
-            </a:r>
-            <a:endParaRPr lang="en-US" sz="1000" dirty="0"/>
-          </a:p>
-        </p:txBody>
-      </p:sp>
-      <p:sp>
-        <p:nvSpPr>
-          <p:cNvPr id="35" name="Shape 33"/>
+          <p:cNvPr id="41" name="Shape 39"/>
           <p:cNvSpPr/>
           <p:nvPr/>
         </p:nvSpPr>
         <p:spPr>
           <a:xfrm>
-            <a:off x="502920" y="4462272"/>
+            <a:off x="502920" y="4882896"/>
             <a:ext cx="7525512" cy="187452"/>
           </a:xfrm>
           <a:prstGeom prst="rect">
@@ -11948,254 +11854,6 @@
           <a:lstStyle/>
           <a:p>
             <a:endParaRPr lang="es-ES" sz="1200"/>
-          </a:p>
-        </p:txBody>
-      </p:sp>
-      <p:sp>
-        <p:nvSpPr>
-          <p:cNvPr id="38" name="Text 36"/>
-          <p:cNvSpPr txBox="1"/>
-          <p:nvPr/>
-        </p:nvSpPr>
-        <p:spPr>
-          <a:xfrm>
-            <a:off x="868680" y="4517136"/>
-            <a:ext cx="2113908" cy="140589"/>
-          </a:xfrm>
-          <a:prstGeom prst="rect">
-            <a:avLst/>
-          </a:prstGeom>
-          <a:noFill/>
-          <a:ln/>
-        </p:spPr>
-        <p:txBody>
-          <a:bodyPr wrap="square" rtlCol="0" anchor="ctr"/>
-          <a:lstStyle/>
-          <a:p>
-            <a:pPr marL="0" indent="0">
-              <a:buNone/>
-            </a:pPr>
-            <a:r>
-              <a:rPr lang="en-US" sz="1000" b="1" dirty="0">
-                <a:solidFill>
-                  <a:srgbClr val="1A1A2E"/>
-                </a:solidFill>
-              </a:rPr>
-              <a:t>Age·Jittering</a:t>
-            </a:r>
-            <a:endParaRPr lang="en-US" sz="1000" dirty="0"/>
-          </a:p>
-        </p:txBody>
-      </p:sp>
-      <p:sp>
-        <p:nvSpPr>
-          <p:cNvPr id="39" name="Text 37"/>
-          <p:cNvSpPr txBox="1"/>
-          <p:nvPr/>
-        </p:nvSpPr>
-        <p:spPr>
-          <a:xfrm>
-            <a:off x="2636520" y="4517136"/>
-            <a:ext cx="1691126" cy="140589"/>
-          </a:xfrm>
-          <a:prstGeom prst="rect">
-            <a:avLst/>
-          </a:prstGeom>
-          <a:noFill/>
-          <a:ln/>
-        </p:spPr>
-        <p:txBody>
-          <a:bodyPr wrap="square" rtlCol="0" anchor="ctr"/>
-          <a:lstStyle/>
-          <a:p>
-            <a:pPr marL="0" indent="0">
-              <a:buNone/>
-            </a:pPr>
-            <a:r>
-              <a:rPr lang="en-US" sz="1000" dirty="0">
-                <a:solidFill>
-                  <a:srgbClr val="7F8C8D"/>
-                </a:solidFill>
-              </a:rPr>
-              <a:t>(T1DGranada / REPLACE-BG)</a:t>
-            </a:r>
-            <a:endParaRPr lang="en-US" sz="1000" dirty="0"/>
-          </a:p>
-        </p:txBody>
-      </p:sp>
-      <p:sp>
-        <p:nvSpPr>
-          <p:cNvPr id="40" name="Text 38"/>
-          <p:cNvSpPr txBox="1"/>
-          <p:nvPr/>
-        </p:nvSpPr>
-        <p:spPr>
-          <a:xfrm>
-            <a:off x="4389120" y="4517136"/>
-            <a:ext cx="3213140" cy="140589"/>
-          </a:xfrm>
-          <a:prstGeom prst="rect">
-            <a:avLst/>
-          </a:prstGeom>
-          <a:noFill/>
-          <a:ln/>
-        </p:spPr>
-        <p:txBody>
-          <a:bodyPr wrap="square" rtlCol="0" anchor="ctr"/>
-          <a:lstStyle/>
-          <a:p>
-            <a:pPr marL="0" indent="0">
-              <a:buNone/>
-            </a:pPr>
-            <a:r>
-              <a:rPr lang="en-US" sz="1000" dirty="0">
-                <a:solidFill>
-                  <a:srgbClr val="1A1A2E"/>
-                </a:solidFill>
-              </a:rPr>
-              <a:t>Mejor Borda en datasets grandes (sin sig. estadística)</a:t>
-            </a:r>
-            <a:endParaRPr lang="en-US" sz="1000" dirty="0"/>
-          </a:p>
-        </p:txBody>
-      </p:sp>
-      <p:sp>
-        <p:nvSpPr>
-          <p:cNvPr id="41" name="Shape 39"/>
-          <p:cNvSpPr/>
-          <p:nvPr/>
-        </p:nvSpPr>
-        <p:spPr>
-          <a:xfrm>
-            <a:off x="502920" y="4882896"/>
-            <a:ext cx="7525512" cy="187452"/>
-          </a:xfrm>
-          <a:prstGeom prst="rect">
-            <a:avLst/>
-          </a:prstGeom>
-          <a:solidFill>
-            <a:srgbClr val="F2F4F8"/>
-          </a:solidFill>
-          <a:ln w="12700">
-            <a:solidFill>
-              <a:srgbClr val="F2F4F8"/>
-            </a:solidFill>
-            <a:prstDash val="solid"/>
-          </a:ln>
-        </p:spPr>
-        <p:txBody>
-          <a:bodyPr/>
-          <a:lstStyle/>
-          <a:p>
-            <a:endParaRPr lang="es-ES" sz="1200"/>
-          </a:p>
-        </p:txBody>
-      </p:sp>
-      <p:sp>
-        <p:nvSpPr>
-          <p:cNvPr id="44" name="Text 42"/>
-          <p:cNvSpPr txBox="1"/>
-          <p:nvPr/>
-        </p:nvSpPr>
-        <p:spPr>
-          <a:xfrm>
-            <a:off x="868680" y="4937760"/>
-            <a:ext cx="2113908" cy="140589"/>
-          </a:xfrm>
-          <a:prstGeom prst="rect">
-            <a:avLst/>
-          </a:prstGeom>
-          <a:noFill/>
-          <a:ln/>
-        </p:spPr>
-        <p:txBody>
-          <a:bodyPr wrap="square" rtlCol="0" anchor="ctr"/>
-          <a:lstStyle/>
-          <a:p>
-            <a:pPr marL="0" indent="0">
-              <a:buNone/>
-            </a:pPr>
-            <a:r>
-              <a:rPr lang="en-US" sz="1000" b="1" dirty="0">
-                <a:solidFill>
-                  <a:srgbClr val="1A1A2E"/>
-                </a:solidFill>
-              </a:rPr>
-              <a:t>Ninguna técnica universal</a:t>
-            </a:r>
-            <a:endParaRPr lang="en-US" sz="1000" dirty="0"/>
-          </a:p>
-        </p:txBody>
-      </p:sp>
-      <p:sp>
-        <p:nvSpPr>
-          <p:cNvPr id="45" name="Text 43"/>
-          <p:cNvSpPr txBox="1"/>
-          <p:nvPr/>
-        </p:nvSpPr>
-        <p:spPr>
-          <a:xfrm>
-            <a:off x="2636520" y="4937760"/>
-            <a:ext cx="1691126" cy="140589"/>
-          </a:xfrm>
-          <a:prstGeom prst="rect">
-            <a:avLst/>
-          </a:prstGeom>
-          <a:noFill/>
-          <a:ln/>
-        </p:spPr>
-        <p:txBody>
-          <a:bodyPr wrap="square" rtlCol="0" anchor="ctr"/>
-          <a:lstStyle/>
-          <a:p>
-            <a:pPr marL="0" indent="0">
-              <a:buNone/>
-            </a:pPr>
-            <a:r>
-              <a:rPr lang="en-US" sz="1000" dirty="0">
-                <a:solidFill>
-                  <a:srgbClr val="7F8C8D"/>
-                </a:solidFill>
-              </a:rPr>
-              <a:t>(Los 3 datasets)</a:t>
-            </a:r>
-            <a:endParaRPr lang="en-US" sz="1000" dirty="0"/>
-          </a:p>
-        </p:txBody>
-      </p:sp>
-      <p:sp>
-        <p:nvSpPr>
-          <p:cNvPr id="46" name="Text 44"/>
-          <p:cNvSpPr txBox="1"/>
-          <p:nvPr/>
-        </p:nvSpPr>
-        <p:spPr>
-          <a:xfrm>
-            <a:off x="4389120" y="4937760"/>
-            <a:ext cx="3213140" cy="140589"/>
-          </a:xfrm>
-          <a:prstGeom prst="rect">
-            <a:avLst/>
-          </a:prstGeom>
-          <a:noFill/>
-          <a:ln/>
-        </p:spPr>
-        <p:txBody>
-          <a:bodyPr wrap="square" rtlCol="0" anchor="ctr"/>
-          <a:lstStyle/>
-          <a:p>
-            <a:pPr marL="0" indent="0">
-              <a:buNone/>
-            </a:pPr>
-            <a:r>
-              <a:rPr lang="en-US" sz="1000" dirty="0">
-                <a:solidFill>
-                  <a:srgbClr val="1A1A2E"/>
-                </a:solidFill>
-              </a:rPr>
-              <a:t>No existe un ganador que domine en todos los escenarios</a:t>
-            </a:r>
-            <a:endParaRPr lang="en-US" sz="1000" dirty="0"/>
           </a:p>
         </p:txBody>
       </p:sp>
@@ -12221,8 +11879,8 @@
         </p:blipFill>
         <p:spPr>
           <a:xfrm>
-            <a:off x="5729273" y="656747"/>
-            <a:ext cx="2385469" cy="3084024"/>
+            <a:off x="5613231" y="685911"/>
+            <a:ext cx="3004989" cy="3884963"/>
           </a:xfrm>
           <a:prstGeom prst="rect">
             <a:avLst/>
@@ -12251,7 +11909,7 @@
         </p:blipFill>
         <p:spPr>
           <a:xfrm>
-            <a:off x="6086168" y="3778488"/>
+            <a:off x="6385041" y="4704408"/>
             <a:ext cx="1461367" cy="178488"/>
           </a:xfrm>
           <a:prstGeom prst="rect">
@@ -12259,6 +11917,189 @@
           </a:prstGeom>
         </p:spPr>
       </p:pic>
+      <p:sp>
+        <p:nvSpPr>
+          <p:cNvPr id="10" name="Rectángulo 9">
+            <a:extLst>
+              <a:ext uri="{FF2B5EF4-FFF2-40B4-BE49-F238E27FC236}">
+                <a16:creationId xmlns:a16="http://schemas.microsoft.com/office/drawing/2014/main" id="{25604D15-71E5-00D6-EDEF-8ADEA75D08CF}"/>
+              </a:ext>
+            </a:extLst>
+          </p:cNvPr>
+          <p:cNvSpPr/>
+          <p:nvPr/>
+        </p:nvSpPr>
+        <p:spPr>
+          <a:xfrm>
+            <a:off x="502920" y="1954211"/>
+            <a:ext cx="3781697" cy="2048256"/>
+          </a:xfrm>
+          <a:prstGeom prst="rect">
+            <a:avLst/>
+          </a:prstGeom>
+          <a:noFill/>
+          <a:ln>
+            <a:solidFill>
+              <a:schemeClr val="accent1">
+                <a:lumMod val="50000"/>
+              </a:schemeClr>
+            </a:solidFill>
+          </a:ln>
+        </p:spPr>
+        <p:style>
+          <a:lnRef idx="2">
+            <a:schemeClr val="accent1">
+              <a:shade val="15000"/>
+            </a:schemeClr>
+          </a:lnRef>
+          <a:fillRef idx="1">
+            <a:schemeClr val="accent1"/>
+          </a:fillRef>
+          <a:effectRef idx="0">
+            <a:schemeClr val="accent1"/>
+          </a:effectRef>
+          <a:fontRef idx="minor">
+            <a:schemeClr val="lt1"/>
+          </a:fontRef>
+        </p:style>
+        <p:txBody>
+          <a:bodyPr rtlCol="0" anchor="ctr"/>
+          <a:lstStyle/>
+          <a:p>
+            <a:pPr algn="ctr"/>
+            <a:endParaRPr lang="es-ES"/>
+          </a:p>
+        </p:txBody>
+      </p:sp>
+      <p:cxnSp>
+        <p:nvCxnSpPr>
+          <p:cNvPr id="22" name="Conector recto 21">
+            <a:extLst>
+              <a:ext uri="{FF2B5EF4-FFF2-40B4-BE49-F238E27FC236}">
+                <a16:creationId xmlns:a16="http://schemas.microsoft.com/office/drawing/2014/main" id="{3DF3EE46-20DE-0104-49D0-62EA95AE9D7C}"/>
+              </a:ext>
+            </a:extLst>
+          </p:cNvPr>
+          <p:cNvCxnSpPr/>
+          <p:nvPr/>
+        </p:nvCxnSpPr>
+        <p:spPr>
+          <a:xfrm>
+            <a:off x="502920" y="2429699"/>
+            <a:ext cx="3781697" cy="0"/>
+          </a:xfrm>
+          <a:prstGeom prst="line">
+            <a:avLst/>
+          </a:prstGeom>
+          <a:ln>
+            <a:solidFill>
+              <a:schemeClr val="accent1">
+                <a:lumMod val="50000"/>
+              </a:schemeClr>
+            </a:solidFill>
+          </a:ln>
+        </p:spPr>
+        <p:style>
+          <a:lnRef idx="1">
+            <a:schemeClr val="accent1"/>
+          </a:lnRef>
+          <a:fillRef idx="0">
+            <a:schemeClr val="accent1"/>
+          </a:fillRef>
+          <a:effectRef idx="0">
+            <a:schemeClr val="accent1"/>
+          </a:effectRef>
+          <a:fontRef idx="minor">
+            <a:schemeClr val="tx1"/>
+          </a:fontRef>
+        </p:style>
+      </p:cxnSp>
+      <p:cxnSp>
+        <p:nvCxnSpPr>
+          <p:cNvPr id="27" name="Conector recto 26">
+            <a:extLst>
+              <a:ext uri="{FF2B5EF4-FFF2-40B4-BE49-F238E27FC236}">
+                <a16:creationId xmlns:a16="http://schemas.microsoft.com/office/drawing/2014/main" id="{306AF0C8-5CF9-CD48-00F2-71D8070FD07F}"/>
+              </a:ext>
+            </a:extLst>
+          </p:cNvPr>
+          <p:cNvCxnSpPr/>
+          <p:nvPr/>
+        </p:nvCxnSpPr>
+        <p:spPr>
+          <a:xfrm>
+            <a:off x="502920" y="2946226"/>
+            <a:ext cx="3781697" cy="0"/>
+          </a:xfrm>
+          <a:prstGeom prst="line">
+            <a:avLst/>
+          </a:prstGeom>
+          <a:ln>
+            <a:solidFill>
+              <a:schemeClr val="accent1">
+                <a:lumMod val="50000"/>
+              </a:schemeClr>
+            </a:solidFill>
+          </a:ln>
+        </p:spPr>
+        <p:style>
+          <a:lnRef idx="1">
+            <a:schemeClr val="accent1"/>
+          </a:lnRef>
+          <a:fillRef idx="0">
+            <a:schemeClr val="accent1"/>
+          </a:fillRef>
+          <a:effectRef idx="0">
+            <a:schemeClr val="accent1"/>
+          </a:effectRef>
+          <a:fontRef idx="minor">
+            <a:schemeClr val="tx1"/>
+          </a:fontRef>
+        </p:style>
+      </p:cxnSp>
+      <p:cxnSp>
+        <p:nvCxnSpPr>
+          <p:cNvPr id="30" name="Conector recto 29">
+            <a:extLst>
+              <a:ext uri="{FF2B5EF4-FFF2-40B4-BE49-F238E27FC236}">
+                <a16:creationId xmlns:a16="http://schemas.microsoft.com/office/drawing/2014/main" id="{D3845CDF-ACBB-1B2A-1839-80A9F0908215}"/>
+              </a:ext>
+            </a:extLst>
+          </p:cNvPr>
+          <p:cNvCxnSpPr/>
+          <p:nvPr/>
+        </p:nvCxnSpPr>
+        <p:spPr>
+          <a:xfrm>
+            <a:off x="502920" y="3456548"/>
+            <a:ext cx="3781697" cy="0"/>
+          </a:xfrm>
+          <a:prstGeom prst="line">
+            <a:avLst/>
+          </a:prstGeom>
+          <a:ln>
+            <a:solidFill>
+              <a:schemeClr val="accent1">
+                <a:lumMod val="50000"/>
+              </a:schemeClr>
+            </a:solidFill>
+          </a:ln>
+        </p:spPr>
+        <p:style>
+          <a:lnRef idx="1">
+            <a:schemeClr val="accent1"/>
+          </a:lnRef>
+          <a:fillRef idx="0">
+            <a:schemeClr val="accent1"/>
+          </a:fillRef>
+          <a:effectRef idx="0">
+            <a:schemeClr val="accent1"/>
+          </a:effectRef>
+          <a:fontRef idx="minor">
+            <a:schemeClr val="tx1"/>
+          </a:fontRef>
+        </p:style>
+      </p:cxnSp>
     </p:spTree>
   </p:cSld>
   <p:clrMapOvr>

</xml_diff>

<commit_message>
fix(memoria): fix CORRECTIONS FRO ORESTI, graphics
</commit_message>
<xml_diff>
--- a/tfm_defensa.pptx
+++ b/tfm_defensa.pptx
@@ -3206,7 +3206,7 @@
                   <a:srgbClr val="1A1A2E"/>
                 </a:solidFill>
               </a:rPr>
-              <a:t>Existe un trade-off estructural: ENTIRE vs. TBR-2</a:t>
+              <a:t>Existe un trade-off estructural: TIR vs. TBR-2</a:t>
             </a:r>
             <a:endParaRPr lang="en-US" sz="1400" dirty="0"/>
           </a:p>
@@ -4013,7 +4013,23 @@
                   <a:srgbClr val="FFFFFF"/>
                 </a:solidFill>
               </a:rPr>
-              <a:t>Primera evaluación sistemática de 10 técnicas de balanceo demográfico sobre señales CGM, con protocolo estadístico formal (Friedman + Nemenyi + Borda + Cohen's d) y evaluación desagregada por rango glucémico en tres datasets reales de distinta escala y estructura.</a:t>
+              <a:t>Primera evaluación sistemática de 10 técnicas de balanceo demográfico sobre señales CGM, con protocolo estadístico formal (Friedman + </a:t>
+            </a:r>
+            <a:r>
+              <a:rPr lang="en-US" sz="1400" dirty="0" err="1">
+                <a:solidFill>
+                  <a:srgbClr val="FFFFFF"/>
+                </a:solidFill>
+              </a:rPr>
+              <a:t>Nemenyi</a:t>
+            </a:r>
+            <a:r>
+              <a:rPr lang="en-US" sz="1400" dirty="0">
+                <a:solidFill>
+                  <a:srgbClr val="FFFFFF"/>
+                </a:solidFill>
+              </a:rPr>
+              <a:t> + Spearman + Borda) y evaluación desagregada por rango glucémico en tres datasets reales de distinta escala y estructura.</a:t>
             </a:r>
             <a:endParaRPr lang="en-US" sz="1400" dirty="0"/>
           </a:p>
@@ -5266,7 +5282,7 @@
         <p:spPr>
           <a:xfrm>
             <a:off x="502920" y="2359152"/>
-            <a:ext cx="2651760" cy="2286000"/>
+            <a:ext cx="2651760" cy="1231392"/>
           </a:xfrm>
           <a:prstGeom prst="rect">
             <a:avLst/>
@@ -5366,7 +5382,7 @@
         <p:spPr>
           <a:xfrm>
             <a:off x="594360" y="2834640"/>
-            <a:ext cx="2468880" cy="1097280"/>
+            <a:ext cx="1874520" cy="527304"/>
           </a:xfrm>
           <a:prstGeom prst="rect">
             <a:avLst/>
@@ -5430,7 +5446,7 @@
         <p:spPr>
           <a:xfrm>
             <a:off x="3291840" y="2359152"/>
-            <a:ext cx="2651760" cy="2286000"/>
+            <a:ext cx="2651760" cy="1231392"/>
           </a:xfrm>
           <a:prstGeom prst="rect">
             <a:avLst/>
@@ -5530,7 +5546,7 @@
         <p:spPr>
           <a:xfrm>
             <a:off x="3383280" y="2834640"/>
-            <a:ext cx="2468880" cy="1097280"/>
+            <a:ext cx="2220686" cy="527304"/>
           </a:xfrm>
           <a:prstGeom prst="rect">
             <a:avLst/>
@@ -5594,7 +5610,7 @@
         <p:spPr>
           <a:xfrm>
             <a:off x="6080760" y="2359152"/>
-            <a:ext cx="2651760" cy="2286000"/>
+            <a:ext cx="2651760" cy="1231392"/>
           </a:xfrm>
           <a:prstGeom prst="rect">
             <a:avLst/>
@@ -5694,7 +5710,7 @@
         <p:spPr>
           <a:xfrm>
             <a:off x="6172200" y="2834640"/>
-            <a:ext cx="2468880" cy="1097280"/>
+            <a:ext cx="2299063" cy="527304"/>
           </a:xfrm>
           <a:prstGeom prst="rect">
             <a:avLst/>
@@ -5757,7 +5773,7 @@
         </p:nvSpPr>
         <p:spPr>
           <a:xfrm>
-            <a:off x="502920" y="4258056"/>
+            <a:off x="6172200" y="3695700"/>
             <a:ext cx="3200400" cy="246888"/>
           </a:xfrm>
           <a:prstGeom prst="rect">
@@ -5793,8 +5809,8 @@
         </p:nvSpPr>
         <p:spPr>
           <a:xfrm>
-            <a:off x="502920" y="4486656"/>
-            <a:ext cx="8138160" cy="320040"/>
+            <a:off x="5603966" y="4164003"/>
+            <a:ext cx="3154680" cy="320040"/>
           </a:xfrm>
           <a:prstGeom prst="rect">
             <a:avLst/>
@@ -5855,6 +5871,52 @@
           <a:bodyPr/>
           <a:lstStyle/>
           <a:p>
+            <a:endParaRPr lang="es-ES"/>
+          </a:p>
+        </p:txBody>
+      </p:sp>
+      <p:sp>
+        <p:nvSpPr>
+          <p:cNvPr id="23" name="Flecha: a la derecha 22">
+            <a:extLst>
+              <a:ext uri="{FF2B5EF4-FFF2-40B4-BE49-F238E27FC236}">
+                <a16:creationId xmlns:a16="http://schemas.microsoft.com/office/drawing/2014/main" id="{4FB4A944-5265-CFFF-67B4-B94E71413B4D}"/>
+              </a:ext>
+            </a:extLst>
+          </p:cNvPr>
+          <p:cNvSpPr/>
+          <p:nvPr/>
+        </p:nvSpPr>
+        <p:spPr>
+          <a:xfrm>
+            <a:off x="566928" y="3892731"/>
+            <a:ext cx="1901952" cy="136725"/>
+          </a:xfrm>
+          <a:prstGeom prst="rightArrow">
+            <a:avLst/>
+          </a:prstGeom>
+        </p:spPr>
+        <p:style>
+          <a:lnRef idx="2">
+            <a:schemeClr val="accent1">
+              <a:shade val="15000"/>
+            </a:schemeClr>
+          </a:lnRef>
+          <a:fillRef idx="1">
+            <a:schemeClr val="accent1"/>
+          </a:fillRef>
+          <a:effectRef idx="0">
+            <a:schemeClr val="accent1"/>
+          </a:effectRef>
+          <a:fontRef idx="minor">
+            <a:schemeClr val="lt1"/>
+          </a:fontRef>
+        </p:style>
+        <p:txBody>
+          <a:bodyPr rtlCol="0" anchor="ctr"/>
+          <a:lstStyle/>
+          <a:p>
+            <a:pPr algn="ctr"/>
             <a:endParaRPr lang="es-ES"/>
           </a:p>
         </p:txBody>
@@ -7690,7 +7752,7 @@
                   <a:srgbClr val="1A1A2E"/>
                 </a:solidFill>
               </a:rPr>
-              <a:t>ROS · RUS · Jittering</a:t>
+              <a:t>ROS · RUS</a:t>
             </a:r>
             <a:endParaRPr lang="en-US" sz="1200" dirty="0"/>
           </a:p>
@@ -7817,16 +7879,29 @@
           <a:bodyPr wrap="square" rtlCol="0" anchor="ctr"/>
           <a:lstStyle/>
           <a:p>
-            <a:pPr marL="0" indent="0">
-              <a:buNone/>
-            </a:pPr>
             <a:r>
               <a:rPr lang="en-US" sz="1200" dirty="0">
                 <a:solidFill>
                   <a:srgbClr val="1A1A2E"/>
                 </a:solidFill>
               </a:rPr>
-              <a:t>SMOTE · Tomek Links · PA-Undersampling</a:t>
+              <a:t>SMOTE · Tomek Links · PA-</a:t>
+            </a:r>
+            <a:r>
+              <a:rPr lang="en-US" sz="1200" dirty="0" err="1">
+                <a:solidFill>
+                  <a:srgbClr val="1A1A2E"/>
+                </a:solidFill>
+              </a:rPr>
+              <a:t>Undersampling</a:t>
+            </a:r>
+            <a:r>
+              <a:rPr lang="en-US" sz="1200" dirty="0">
+                <a:solidFill>
+                  <a:srgbClr val="1A1A2E"/>
+                </a:solidFill>
+              </a:rPr>
+              <a:t> · Jittering</a:t>
             </a:r>
             <a:endParaRPr lang="en-US" sz="1200" dirty="0"/>
           </a:p>
@@ -8054,12 +8129,60 @@
               <a:buNone/>
             </a:pPr>
             <a:r>
+              <a:rPr lang="en-US" sz="2800" b="1" dirty="0" err="1">
+                <a:solidFill>
+                  <a:srgbClr val="1A1A2E"/>
+                </a:solidFill>
+              </a:rPr>
+              <a:t>Efecto</a:t>
+            </a:r>
+            <a:r>
               <a:rPr lang="en-US" sz="2800" b="1" dirty="0">
                 <a:solidFill>
                   <a:srgbClr val="1A1A2E"/>
                 </a:solidFill>
               </a:rPr>
-              <a:t>El balanceo reshapeaba el entrenamiento — pero de forma muy diferente por dataset</a:t>
+              <a:t> del </a:t>
+            </a:r>
+            <a:r>
+              <a:rPr lang="en-US" sz="2800" b="1" dirty="0" err="1">
+                <a:solidFill>
+                  <a:srgbClr val="1A1A2E"/>
+                </a:solidFill>
+              </a:rPr>
+              <a:t>balanceo</a:t>
+            </a:r>
+            <a:r>
+              <a:rPr lang="en-US" sz="2800" b="1" dirty="0">
+                <a:solidFill>
+                  <a:srgbClr val="1A1A2E"/>
+                </a:solidFill>
+              </a:rPr>
+              <a:t> </a:t>
+            </a:r>
+            <a:r>
+              <a:rPr lang="en-US" sz="2800" b="1" dirty="0" err="1">
+                <a:solidFill>
+                  <a:srgbClr val="1A1A2E"/>
+                </a:solidFill>
+              </a:rPr>
+              <a:t>sobre</a:t>
+            </a:r>
+            <a:r>
+              <a:rPr lang="en-US" sz="2800" b="1" dirty="0">
+                <a:solidFill>
+                  <a:srgbClr val="1A1A2E"/>
+                </a:solidFill>
+              </a:rPr>
+              <a:t> el </a:t>
+            </a:r>
+            <a:r>
+              <a:rPr lang="en-US" sz="2800" b="1" dirty="0" err="1">
+                <a:solidFill>
+                  <a:srgbClr val="1A1A2E"/>
+                </a:solidFill>
+              </a:rPr>
+              <a:t>entrenamiento</a:t>
             </a:r>
             <a:endParaRPr lang="en-US" sz="2800" dirty="0"/>
           </a:p>
@@ -10651,7 +10774,7 @@
                   <a:srgbClr val="1A1A2E"/>
                 </a:solidFill>
               </a:rPr>
-              <a:t>Ninguna técnica gana en todo: el trade-off ENTIRE vs. TBR-2</a:t>
+              <a:t>Ninguna técnica gana en todo: el trade-off TIR vs. TBR-2</a:t>
             </a:r>
             <a:endParaRPr lang="en-US" sz="2800" dirty="0"/>
           </a:p>
@@ -11349,8 +11472,8 @@
         </p:nvSpPr>
         <p:spPr>
           <a:xfrm>
-            <a:off x="502920" y="2429699"/>
-            <a:ext cx="64008" cy="580644"/>
+            <a:off x="502920" y="2429698"/>
+            <a:ext cx="64008" cy="685797"/>
           </a:xfrm>
           <a:prstGeom prst="rect">
             <a:avLst/>
@@ -11489,8 +11612,8 @@
         </p:nvSpPr>
         <p:spPr>
           <a:xfrm>
-            <a:off x="502920" y="2893427"/>
-            <a:ext cx="8138160" cy="475488"/>
+            <a:off x="502920" y="2963857"/>
+            <a:ext cx="8138160" cy="405057"/>
           </a:xfrm>
           <a:prstGeom prst="rect">
             <a:avLst/>
@@ -11521,8 +11644,8 @@
         </p:nvSpPr>
         <p:spPr>
           <a:xfrm>
-            <a:off x="502920" y="2978339"/>
-            <a:ext cx="64008" cy="475488"/>
+            <a:off x="502920" y="2965276"/>
+            <a:ext cx="64008" cy="478209"/>
           </a:xfrm>
           <a:prstGeom prst="rect">
             <a:avLst/>
@@ -11790,38 +11913,6 @@
               <a:t>p = 0,140</a:t>
             </a:r>
             <a:endParaRPr lang="en-US" sz="1000" dirty="0"/>
-          </a:p>
-        </p:txBody>
-      </p:sp>
-      <p:sp>
-        <p:nvSpPr>
-          <p:cNvPr id="29" name="Shape 27"/>
-          <p:cNvSpPr/>
-          <p:nvPr/>
-        </p:nvSpPr>
-        <p:spPr>
-          <a:xfrm>
-            <a:off x="502920" y="4329035"/>
-            <a:ext cx="7525512" cy="187452"/>
-          </a:xfrm>
-          <a:prstGeom prst="rect">
-            <a:avLst/>
-          </a:prstGeom>
-          <a:solidFill>
-            <a:srgbClr val="F2F4F8"/>
-          </a:solidFill>
-          <a:ln w="12700">
-            <a:solidFill>
-              <a:srgbClr val="F2F4F8"/>
-            </a:solidFill>
-            <a:prstDash val="solid"/>
-          </a:ln>
-        </p:spPr>
-        <p:txBody>
-          <a:bodyPr/>
-          <a:lstStyle/>
-          <a:p>
-            <a:endParaRPr lang="es-ES" sz="1200"/>
           </a:p>
         </p:txBody>
       </p:sp>
@@ -12071,7 +12162,7 @@
         </p:nvCxnSpPr>
         <p:spPr>
           <a:xfrm>
-            <a:off x="502920" y="3456548"/>
+            <a:off x="502920" y="3436955"/>
             <a:ext cx="3781697" cy="0"/>
           </a:xfrm>
           <a:prstGeom prst="line">

</xml_diff>